<commit_message>
Normalize presentation generator text
Co-authored-by: Bharathkte247 <Bharathkte247@users.noreply.github.com>
</commit_message>
<xml_diff>
--- a/Report_Gap_Analysis_Presentation.pptx
+++ b/Report_Gap_Analysis_Presentation.pptx
@@ -4561,7 +4561,7 @@
                 </a:solidFill>
                 <a:latin typeface="Aptos"/>
               </a:rPr>
-              <a:t>✓ Report runs without errors</a:t>
+              <a:t>[OK] Report runs without errors</a:t>
             </a:r>
           </a:p>
         </p:txBody>
@@ -4615,7 +4615,7 @@
                 </a:solidFill>
                 <a:latin typeface="Aptos"/>
               </a:rPr>
-              <a:t>✓ Field mappings verified</a:t>
+              <a:t>[OK] Field mappings verified</a:t>
             </a:r>
           </a:p>
         </p:txBody>
@@ -4669,7 +4669,7 @@
                 </a:solidFill>
                 <a:latin typeface="Aptos"/>
               </a:rPr>
-              <a:t>✓ Filters include new deployment values</a:t>
+              <a:t>[OK] Filters include new deployment values</a:t>
             </a:r>
           </a:p>
         </p:txBody>
@@ -4723,7 +4723,7 @@
                 </a:solidFill>
                 <a:latin typeface="Aptos"/>
               </a:rPr>
-              <a:t>✓ KPI formulas reconciled</a:t>
+              <a:t>[OK] KPI formulas reconciled</a:t>
             </a:r>
           </a:p>
         </p:txBody>
@@ -4777,7 +4777,7 @@
                 </a:solidFill>
                 <a:latin typeface="Aptos"/>
               </a:rPr>
-              <a:t>✓ Dashboard refresh tested</a:t>
+              <a:t>[OK] Dashboard refresh tested</a:t>
             </a:r>
           </a:p>
         </p:txBody>
@@ -4831,7 +4831,7 @@
                 </a:solidFill>
                 <a:latin typeface="Aptos"/>
               </a:rPr>
-              <a:t>✓ Business owner sign-off captured</a:t>
+              <a:t>[OK] Business owner sign-off captured</a:t>
             </a:r>
           </a:p>
         </p:txBody>
@@ -12149,7 +12149,7 @@
                 </a:solidFill>
                 <a:latin typeface="Aptos"/>
               </a:rPr>
-              <a:t>High Impact — Executive decisions, compliance submissions, external reporting</a:t>
+              <a:t>High Impact - Executive decisions, compliance submissions, external reporting</a:t>
             </a:r>
           </a:p>
         </p:txBody>
@@ -12203,7 +12203,7 @@
                 </a:solidFill>
                 <a:latin typeface="Aptos"/>
               </a:rPr>
-              <a:t>Medium Impact — Operational tracking, forecast accuracy, adoption confidence</a:t>
+              <a:t>Medium Impact - Operational tracking, forecast accuracy, adoption confidence</a:t>
             </a:r>
           </a:p>
         </p:txBody>
@@ -12257,7 +12257,7 @@
                 </a:solidFill>
                 <a:latin typeface="Aptos"/>
               </a:rPr>
-              <a:t>Low Impact — Low-frequency reports or non-critical supporting views</a:t>
+              <a:t>Low Impact - Low-frequency reports or non-critical supporting views</a:t>
             </a:r>
           </a:p>
         </p:txBody>

</xml_diff>